<commit_message>
Update A-Share Blast Lab / 2026-10-29 daily-18:05
</commit_message>
<xml_diff>
--- a/assets/多空阶段简报_2026-10-29.pptx
+++ b/assets/多空阶段简报_2026-10-29.pptx
@@ -193,16 +193,16 @@
                 <c:formatCode>General</c:formatCode>
                 <c:ptCount val="4"/>
                 <c:pt idx="0">
-                  <c:v>4</c:v>
+                  <c:v>1</c:v>
                 </c:pt>
                 <c:pt idx="1">
-                  <c:v>9</c:v>
+                  <c:v>7</c:v>
                 </c:pt>
                 <c:pt idx="2">
-                  <c:v>0</c:v>
+                  <c:v>1</c:v>
                 </c:pt>
                 <c:pt idx="3">
-                  <c:v>5</c:v>
+                  <c:v>9</c:v>
                 </c:pt>
               </c:numCache>
             </c:numRef>
@@ -331,28 +331,28 @@
                   <c:v>商业航天</c:v>
                 </c:pt>
                 <c:pt idx="1">
+                  <c:v>药</c:v>
+                </c:pt>
+                <c:pt idx="2">
                   <c:v>AI应用</c:v>
                 </c:pt>
-                <c:pt idx="2">
-                  <c:v>MLCC</c:v>
-                </c:pt>
                 <c:pt idx="3">
-                  <c:v>药</c:v>
+                  <c:v>黄金白银</c:v>
                 </c:pt>
                 <c:pt idx="4">
                   <c:v>散热液冷</c:v>
                 </c:pt>
                 <c:pt idx="5">
-                  <c:v>黄金白银</c:v>
+                  <c:v>电力</c:v>
                 </c:pt>
                 <c:pt idx="6">
+                  <c:v>半导体上游</c:v>
+                </c:pt>
+                <c:pt idx="7">
                   <c:v>PCB</c:v>
                 </c:pt>
-                <c:pt idx="7">
-                  <c:v>机器人</c:v>
-                </c:pt>
                 <c:pt idx="8">
-                  <c:v>电力</c:v>
+                  <c:v>MLCC</c:v>
                 </c:pt>
               </c:strCache>
             </c:strRef>
@@ -364,25 +364,25 @@
                 <c:formatCode>General</c:formatCode>
                 <c:ptCount val="9"/>
                 <c:pt idx="0">
-                  <c:v>23</c:v>
+                  <c:v>21</c:v>
                 </c:pt>
                 <c:pt idx="1">
-                  <c:v>14</c:v>
+                  <c:v>18</c:v>
                 </c:pt>
                 <c:pt idx="2">
-                  <c:v>0</c:v>
+                  <c:v>9</c:v>
                 </c:pt>
                 <c:pt idx="3">
-                  <c:v>19</c:v>
+                  <c:v>2</c:v>
                 </c:pt>
                 <c:pt idx="4">
                   <c:v>1</c:v>
                 </c:pt>
                 <c:pt idx="5">
-                  <c:v>2</c:v>
+                  <c:v>1</c:v>
                 </c:pt>
                 <c:pt idx="6">
-                  <c:v>4</c:v>
+                  <c:v>1</c:v>
                 </c:pt>
                 <c:pt idx="7">
                   <c:v>2</c:v>
@@ -448,28 +448,28 @@
                   <c:v>商业航天</c:v>
                 </c:pt>
                 <c:pt idx="1">
+                  <c:v>药</c:v>
+                </c:pt>
+                <c:pt idx="2">
                   <c:v>AI应用</c:v>
                 </c:pt>
-                <c:pt idx="2">
-                  <c:v>MLCC</c:v>
-                </c:pt>
                 <c:pt idx="3">
-                  <c:v>药</c:v>
+                  <c:v>黄金白银</c:v>
                 </c:pt>
                 <c:pt idx="4">
                   <c:v>散热液冷</c:v>
                 </c:pt>
                 <c:pt idx="5">
-                  <c:v>黄金白银</c:v>
+                  <c:v>电力</c:v>
                 </c:pt>
                 <c:pt idx="6">
+                  <c:v>半导体上游</c:v>
+                </c:pt>
+                <c:pt idx="7">
                   <c:v>PCB</c:v>
                 </c:pt>
-                <c:pt idx="7">
-                  <c:v>机器人</c:v>
-                </c:pt>
                 <c:pt idx="8">
-                  <c:v>电力</c:v>
+                  <c:v>MLCC</c:v>
                 </c:pt>
               </c:strCache>
             </c:strRef>
@@ -484,28 +484,28 @@
                   <c:v>2</c:v>
                 </c:pt>
                 <c:pt idx="1">
-                  <c:v>5</c:v>
+                  <c:v>4</c:v>
                 </c:pt>
                 <c:pt idx="2">
-                  <c:v>1</c:v>
+                  <c:v>2</c:v>
                 </c:pt>
                 <c:pt idx="3">
-                  <c:v>3</c:v>
+                  <c:v>0</c:v>
                 </c:pt>
                 <c:pt idx="4">
                   <c:v>1</c:v>
                 </c:pt>
                 <c:pt idx="5">
+                  <c:v>1</c:v>
+                </c:pt>
+                <c:pt idx="6">
+                  <c:v>1</c:v>
+                </c:pt>
+                <c:pt idx="7">
                   <c:v>0</c:v>
                 </c:pt>
-                <c:pt idx="6">
+                <c:pt idx="8">
                   <c:v>0</c:v>
-                </c:pt>
-                <c:pt idx="7">
-                  <c:v>2</c:v>
-                </c:pt>
-                <c:pt idx="8">
-                  <c:v>1</c:v>
                 </c:pt>
               </c:numCache>
             </c:numRef>
@@ -542,28 +542,28 @@
                   <c:v>商业航天</c:v>
                 </c:pt>
                 <c:pt idx="1">
+                  <c:v>药</c:v>
+                </c:pt>
+                <c:pt idx="2">
                   <c:v>AI应用</c:v>
                 </c:pt>
-                <c:pt idx="2">
-                  <c:v>MLCC</c:v>
-                </c:pt>
                 <c:pt idx="3">
-                  <c:v>药</c:v>
+                  <c:v>黄金白银</c:v>
                 </c:pt>
                 <c:pt idx="4">
                   <c:v>散热液冷</c:v>
                 </c:pt>
                 <c:pt idx="5">
-                  <c:v>黄金白银</c:v>
+                  <c:v>电力</c:v>
                 </c:pt>
                 <c:pt idx="6">
+                  <c:v>半导体上游</c:v>
+                </c:pt>
+                <c:pt idx="7">
                   <c:v>PCB</c:v>
                 </c:pt>
-                <c:pt idx="7">
-                  <c:v>机器人</c:v>
-                </c:pt>
                 <c:pt idx="8">
-                  <c:v>电力</c:v>
+                  <c:v>MLCC</c:v>
                 </c:pt>
               </c:strCache>
             </c:strRef>
@@ -581,19 +581,19 @@
                   <c:v>0</c:v>
                 </c:pt>
                 <c:pt idx="2">
-                  <c:v>1</c:v>
+                  <c:v>0</c:v>
                 </c:pt>
                 <c:pt idx="3">
                   <c:v>0</c:v>
                 </c:pt>
                 <c:pt idx="4">
-                  <c:v>1</c:v>
+                  <c:v>0</c:v>
                 </c:pt>
                 <c:pt idx="5">
                   <c:v>0</c:v>
                 </c:pt>
                 <c:pt idx="6">
-                  <c:v>1</c:v>
+                  <c:v>0</c:v>
                 </c:pt>
                 <c:pt idx="7">
                   <c:v>0</c:v>
@@ -777,28 +777,28 @@
                   <c:v>商业航天</c:v>
                 </c:pt>
                 <c:pt idx="1">
+                  <c:v>药</c:v>
+                </c:pt>
+                <c:pt idx="2">
                   <c:v>AI应用</c:v>
                 </c:pt>
-                <c:pt idx="2">
-                  <c:v>MLCC</c:v>
-                </c:pt>
                 <c:pt idx="3">
-                  <c:v>药</c:v>
+                  <c:v>黄金白银</c:v>
                 </c:pt>
                 <c:pt idx="4">
                   <c:v>散热液冷</c:v>
                 </c:pt>
                 <c:pt idx="5">
-                  <c:v>黄金白银</c:v>
+                  <c:v>电力</c:v>
                 </c:pt>
                 <c:pt idx="6">
+                  <c:v>半导体上游</c:v>
+                </c:pt>
+                <c:pt idx="7">
                   <c:v>PCB</c:v>
                 </c:pt>
-                <c:pt idx="7">
-                  <c:v>机器人</c:v>
-                </c:pt>
                 <c:pt idx="8">
-                  <c:v>电力</c:v>
+                  <c:v>MLCC</c:v>
                 </c:pt>
               </c:strCache>
             </c:strRef>
@@ -810,31 +810,31 @@
                 <c:formatCode>General</c:formatCode>
                 <c:ptCount val="9"/>
                 <c:pt idx="0">
-                  <c:v>67.7</c:v>
+                  <c:v>64.5</c:v>
                 </c:pt>
                 <c:pt idx="1">
-                  <c:v>31.7</c:v>
+                  <c:v>16.3</c:v>
                 </c:pt>
                 <c:pt idx="2">
-                  <c:v>31.2</c:v>
+                  <c:v>14.8</c:v>
                 </c:pt>
                 <c:pt idx="3">
-                  <c:v>16.9</c:v>
+                  <c:v>9.1</c:v>
                 </c:pt>
                 <c:pt idx="4">
-                  <c:v>14.6</c:v>
+                  <c:v>7.3</c:v>
                 </c:pt>
                 <c:pt idx="5">
-                  <c:v>9.1</c:v>
+                  <c:v>6.2</c:v>
                 </c:pt>
                 <c:pt idx="6">
-                  <c:v>8.6</c:v>
+                  <c:v>2.0</c:v>
                 </c:pt>
                 <c:pt idx="7">
-                  <c:v>4.3</c:v>
+                  <c:v>0.0</c:v>
                 </c:pt>
                 <c:pt idx="8">
-                  <c:v>3.2</c:v>
+                  <c:v>0.0</c:v>
                 </c:pt>
               </c:numCache>
             </c:numRef>
@@ -1351,7 +1351,7 @@
           <a:lstStyle/>
           <a:p>
             <a:r>
-              <a:t>当日共 18 个分组；改善 13、恶化 5。转多力度第一为 商业航天，强度 67.74。最强低位转势候选为 MLCC。</a:t>
+              <a:t>当日共 18 个分组；改善 8、恶化 9。转多力度第一为 商业航天，强度 64.52。最强低位转势候选为 商业航天。</a:t>
             </a:r>
           </a:p>
         </p:txBody>
@@ -1421,7 +1421,7 @@
           <a:lstStyle/>
           <a:p>
             <a:r>
-              <a:t>堆叠柱分别代表空转空转多、空转多转多、空直接转多。后两者更接近真实转多确认，空转空转多则是下一轮候选。最强低位转势候选：MLCC。</a:t>
+              <a:t>堆叠柱分别代表空转空转多、空转多转多、空直接转多。后两者更接近真实转多确认，空转空转多则是下一轮候选。最强低位转势候选：商业航天。</a:t>
             </a:r>
           </a:p>
         </p:txBody>
@@ -1561,7 +1561,7 @@
           <a:lstStyle/>
           <a:p>
             <a:r>
-              <a:t>次日先看空转多转多能否继续扩散，再检查空转空转多的蓄势池。反向压力主要来自：算力 转空 9 只｜电网设备 转空 8 只｜半导体芯片 转空 5 只｜存储 转空 3 只。</a:t>
+              <a:t>次日先看空转多转多能否继续扩散，再检查空转空转多的蓄势池。反向压力主要来自：算力 转空 10 只｜电网设备 转空 9 只｜半导体芯片 转空 6 只｜存储 转空 4 只。</a:t>
             </a:r>
           </a:p>
         </p:txBody>
@@ -4955,7 +4955,7 @@
                 </a:solidFill>
                 <a:latin typeface="Microsoft YaHei"/>
               </a:rPr>
-              <a:t>改善 13 · 恶化 5</a:t>
+              <a:t>改善 8 · 恶化 9</a:t>
             </a:r>
           </a:p>
         </p:txBody>
@@ -5129,7 +5129,7 @@
                 </a:solidFill>
                 <a:latin typeface="Microsoft YaHei"/>
               </a:rPr>
-              <a:t>8</a:t>
+              <a:t>5</a:t>
             </a:r>
           </a:p>
         </p:txBody>
@@ -5345,7 +5345,7 @@
                 </a:solidFill>
                 <a:latin typeface="Microsoft YaHei"/>
               </a:rPr>
-              <a:t>8</a:t>
+              <a:t>6</a:t>
             </a:r>
           </a:p>
         </p:txBody>
@@ -5603,7 +5603,7 @@
                 </a:solidFill>
                 <a:latin typeface="Microsoft YaHei"/>
               </a:rPr>
-              <a:t>强度 67.7</a:t>
+              <a:t>强度 64.5</a:t>
             </a:r>
           </a:p>
         </p:txBody>
@@ -5794,7 +5794,7 @@
                 </a:solidFill>
                 <a:latin typeface="Microsoft YaHei"/>
               </a:rPr>
-              <a:t>商业航天转多确认最强，MLCC以多占比 18.8% 成为最强低位转势候选，但同时提防算力、电网设备等反向转空。</a:t>
+              <a:t>商业航天转多确认最强，商业航天以多占比 29.0% 成为最强低位转势候选，但同时提防算力、电网设备等反向转空。</a:t>
             </a:r>
           </a:p>
         </p:txBody>
@@ -5923,7 +5923,7 @@
                 </a:solidFill>
                 <a:latin typeface="Microsoft YaHei"/>
               </a:rPr>
-              <a:t>MLCC</a:t>
+              <a:t>商业航天</a:t>
             </a:r>
           </a:p>
         </p:txBody>
@@ -6181,7 +6181,7 @@
                 </a:solidFill>
                 <a:latin typeface="Microsoft YaHei"/>
               </a:rPr>
-              <a:t>8 个</a:t>
+              <a:t>6 个</a:t>
             </a:r>
           </a:p>
         </p:txBody>
@@ -6782,7 +6782,7 @@
                 </a:solidFill>
                 <a:latin typeface="Microsoft YaHei"/>
               </a:rPr>
-              <a:t>AI应用</a:t>
+              <a:t>药</a:t>
             </a:r>
           </a:p>
         </p:txBody>
@@ -6824,7 +6824,7 @@
                 </a:solidFill>
                 <a:latin typeface="Microsoft YaHei"/>
               </a:rPr>
-              <a:t>5 只｜多占比 23.9%</a:t>
+              <a:t>4 只｜多占比 13.0%</a:t>
             </a:r>
           </a:p>
         </p:txBody>
@@ -6953,7 +6953,7 @@
                 </a:solidFill>
                 <a:latin typeface="Microsoft YaHei"/>
               </a:rPr>
-              <a:t>MLCC</a:t>
+              <a:t>商业航天</a:t>
             </a:r>
           </a:p>
         </p:txBody>
@@ -6995,7 +6995,7 @@
                 </a:solidFill>
                 <a:latin typeface="Microsoft YaHei"/>
               </a:rPr>
-              <a:t>多占比 18.8%｜空转多→多 1 只｜空→空转多 0 只</a:t>
+              <a:t>多占比 29.0%｜空转多→多 2 只｜空→空转多 21 只</a:t>
             </a:r>
           </a:p>
         </p:txBody>
@@ -7421,7 +7421,7 @@
                 </a:solidFill>
                 <a:latin typeface="Microsoft YaHei"/>
               </a:rPr>
-              <a:t>商业航天  ·  67.7</a:t>
+              <a:t>商业航天  ·  64.5</a:t>
             </a:r>
           </a:p>
         </p:txBody>
@@ -7611,7 +7611,7 @@
                         </a:defRPr>
                       </a:pPr>
                       <a:r>
-                        <a:t>67.7</a:t>
+                        <a:t>64.5</a:t>
                       </a:r>
                     </a:p>
                   </a:txBody>
@@ -7685,7 +7685,7 @@
                         </a:defRPr>
                       </a:pPr>
                       <a:r>
-                        <a:t>AI应用</a:t>
+                        <a:t>药</a:t>
                       </a:r>
                     </a:p>
                   </a:txBody>
@@ -7709,7 +7709,7 @@
                         </a:defRPr>
                       </a:pPr>
                       <a:r>
-                        <a:t>31.7</a:t>
+                        <a:t>16.3</a:t>
                       </a:r>
                     </a:p>
                   </a:txBody>
@@ -7733,7 +7733,7 @@
                         </a:defRPr>
                       </a:pPr>
                       <a:r>
-                        <a:t>5只</a:t>
+                        <a:t>4只</a:t>
                       </a:r>
                     </a:p>
                   </a:txBody>
@@ -7783,7 +7783,7 @@
                         </a:defRPr>
                       </a:pPr>
                       <a:r>
-                        <a:t>MLCC</a:t>
+                        <a:t>AI应用</a:t>
                       </a:r>
                     </a:p>
                   </a:txBody>
@@ -7807,7 +7807,7 @@
                         </a:defRPr>
                       </a:pPr>
                       <a:r>
-                        <a:t>31.2</a:t>
+                        <a:t>14.8</a:t>
                       </a:r>
                     </a:p>
                   </a:txBody>
@@ -7831,7 +7831,7 @@
                         </a:defRPr>
                       </a:pPr>
                       <a:r>
-                        <a:t>1只</a:t>
+                        <a:t>2只</a:t>
                       </a:r>
                     </a:p>
                   </a:txBody>
@@ -7858,202 +7858,6 @@
                       </a:pPr>
                       <a:r>
                         <a:t>4</a:t>
-                      </a:r>
-                    </a:p>
-                  </a:txBody>
-                  <a:tcPr marL="54864" marR="54864">
-                    <a:solidFill>
-                      <a:srgbClr val="F7F9FC"/>
-                    </a:solidFill>
-                  </a:tcPr>
-                </a:tc>
-                <a:tc>
-                  <a:txBody>
-                    <a:bodyPr/>
-                    <a:lstStyle/>
-                    <a:p>
-                      <a:pPr algn="l">
-                        <a:defRPr sz="900" b="1">
-                          <a:solidFill>
-                            <a:srgbClr val="233242"/>
-                          </a:solidFill>
-                          <a:latin typeface="Microsoft YaHei"/>
-                        </a:defRPr>
-                      </a:pPr>
-                      <a:r>
-                        <a:t>药</a:t>
-                      </a:r>
-                    </a:p>
-                  </a:txBody>
-                  <a:tcPr marL="54864" marR="54864">
-                    <a:solidFill>
-                      <a:srgbClr val="F7F9FC"/>
-                    </a:solidFill>
-                  </a:tcPr>
-                </a:tc>
-                <a:tc>
-                  <a:txBody>
-                    <a:bodyPr/>
-                    <a:lstStyle/>
-                    <a:p>
-                      <a:pPr algn="ctr">
-                        <a:defRPr sz="900" b="0">
-                          <a:solidFill>
-                            <a:srgbClr val="D34347"/>
-                          </a:solidFill>
-                          <a:latin typeface="Microsoft YaHei"/>
-                        </a:defRPr>
-                      </a:pPr>
-                      <a:r>
-                        <a:t>16.9</a:t>
-                      </a:r>
-                    </a:p>
-                  </a:txBody>
-                  <a:tcPr marL="54864" marR="54864">
-                    <a:solidFill>
-                      <a:srgbClr val="F7F9FC"/>
-                    </a:solidFill>
-                  </a:tcPr>
-                </a:tc>
-                <a:tc>
-                  <a:txBody>
-                    <a:bodyPr/>
-                    <a:lstStyle/>
-                    <a:p>
-                      <a:pPr algn="ctr">
-                        <a:defRPr sz="900" b="0">
-                          <a:solidFill>
-                            <a:srgbClr val="233242"/>
-                          </a:solidFill>
-                          <a:latin typeface="Microsoft YaHei"/>
-                        </a:defRPr>
-                      </a:pPr>
-                      <a:r>
-                        <a:t>3只</a:t>
-                      </a:r>
-                    </a:p>
-                  </a:txBody>
-                  <a:tcPr marL="54864" marR="54864">
-                    <a:solidFill>
-                      <a:srgbClr val="F7F9FC"/>
-                    </a:solidFill>
-                  </a:tcPr>
-                </a:tc>
-              </a:tr>
-              <a:tr h="429768">
-                <a:tc>
-                  <a:txBody>
-                    <a:bodyPr/>
-                    <a:lstStyle/>
-                    <a:p>
-                      <a:pPr algn="ctr">
-                        <a:defRPr sz="900" b="0">
-                          <a:solidFill>
-                            <a:srgbClr val="233242"/>
-                          </a:solidFill>
-                          <a:latin typeface="Microsoft YaHei"/>
-                        </a:defRPr>
-                      </a:pPr>
-                      <a:r>
-                        <a:t>5</a:t>
-                      </a:r>
-                    </a:p>
-                  </a:txBody>
-                  <a:tcPr marL="54864" marR="54864">
-                    <a:solidFill>
-                      <a:srgbClr val="FFFFFF"/>
-                    </a:solidFill>
-                  </a:tcPr>
-                </a:tc>
-                <a:tc>
-                  <a:txBody>
-                    <a:bodyPr/>
-                    <a:lstStyle/>
-                    <a:p>
-                      <a:pPr algn="l">
-                        <a:defRPr sz="900" b="1">
-                          <a:solidFill>
-                            <a:srgbClr val="233242"/>
-                          </a:solidFill>
-                          <a:latin typeface="Microsoft YaHei"/>
-                        </a:defRPr>
-                      </a:pPr>
-                      <a:r>
-                        <a:t>散热液冷</a:t>
-                      </a:r>
-                    </a:p>
-                  </a:txBody>
-                  <a:tcPr marL="54864" marR="54864">
-                    <a:solidFill>
-                      <a:srgbClr val="FFFFFF"/>
-                    </a:solidFill>
-                  </a:tcPr>
-                </a:tc>
-                <a:tc>
-                  <a:txBody>
-                    <a:bodyPr/>
-                    <a:lstStyle/>
-                    <a:p>
-                      <a:pPr algn="ctr">
-                        <a:defRPr sz="900" b="0">
-                          <a:solidFill>
-                            <a:srgbClr val="D34347"/>
-                          </a:solidFill>
-                          <a:latin typeface="Microsoft YaHei"/>
-                        </a:defRPr>
-                      </a:pPr>
-                      <a:r>
-                        <a:t>14.6</a:t>
-                      </a:r>
-                    </a:p>
-                  </a:txBody>
-                  <a:tcPr marL="54864" marR="54864">
-                    <a:solidFill>
-                      <a:srgbClr val="FFFFFF"/>
-                    </a:solidFill>
-                  </a:tcPr>
-                </a:tc>
-                <a:tc>
-                  <a:txBody>
-                    <a:bodyPr/>
-                    <a:lstStyle/>
-                    <a:p>
-                      <a:pPr algn="ctr">
-                        <a:defRPr sz="900" b="0">
-                          <a:solidFill>
-                            <a:srgbClr val="233242"/>
-                          </a:solidFill>
-                          <a:latin typeface="Microsoft YaHei"/>
-                        </a:defRPr>
-                      </a:pPr>
-                      <a:r>
-                        <a:t>1只</a:t>
-                      </a:r>
-                    </a:p>
-                  </a:txBody>
-                  <a:tcPr marL="54864" marR="54864">
-                    <a:solidFill>
-                      <a:srgbClr val="FFFFFF"/>
-                    </a:solidFill>
-                  </a:tcPr>
-                </a:tc>
-              </a:tr>
-              <a:tr h="429768">
-                <a:tc>
-                  <a:txBody>
-                    <a:bodyPr/>
-                    <a:lstStyle/>
-                    <a:p>
-                      <a:pPr algn="ctr">
-                        <a:defRPr sz="900" b="0">
-                          <a:solidFill>
-                            <a:srgbClr val="233242"/>
-                          </a:solidFill>
-                          <a:latin typeface="Microsoft YaHei"/>
-                        </a:defRPr>
-                      </a:pPr>
-                      <a:r>
-                        <a:t>6</a:t>
                       </a:r>
                     </a:p>
                   </a:txBody>
@@ -8136,6 +7940,202 @@
                   </a:tcPr>
                 </a:tc>
               </a:tr>
+              <a:tr h="429768">
+                <a:tc>
+                  <a:txBody>
+                    <a:bodyPr/>
+                    <a:lstStyle/>
+                    <a:p>
+                      <a:pPr algn="ctr">
+                        <a:defRPr sz="900" b="0">
+                          <a:solidFill>
+                            <a:srgbClr val="233242"/>
+                          </a:solidFill>
+                          <a:latin typeface="Microsoft YaHei"/>
+                        </a:defRPr>
+                      </a:pPr>
+                      <a:r>
+                        <a:t>5</a:t>
+                      </a:r>
+                    </a:p>
+                  </a:txBody>
+                  <a:tcPr marL="54864" marR="54864">
+                    <a:solidFill>
+                      <a:srgbClr val="FFFFFF"/>
+                    </a:solidFill>
+                  </a:tcPr>
+                </a:tc>
+                <a:tc>
+                  <a:txBody>
+                    <a:bodyPr/>
+                    <a:lstStyle/>
+                    <a:p>
+                      <a:pPr algn="l">
+                        <a:defRPr sz="900" b="1">
+                          <a:solidFill>
+                            <a:srgbClr val="233242"/>
+                          </a:solidFill>
+                          <a:latin typeface="Microsoft YaHei"/>
+                        </a:defRPr>
+                      </a:pPr>
+                      <a:r>
+                        <a:t>散热液冷</a:t>
+                      </a:r>
+                    </a:p>
+                  </a:txBody>
+                  <a:tcPr marL="54864" marR="54864">
+                    <a:solidFill>
+                      <a:srgbClr val="FFFFFF"/>
+                    </a:solidFill>
+                  </a:tcPr>
+                </a:tc>
+                <a:tc>
+                  <a:txBody>
+                    <a:bodyPr/>
+                    <a:lstStyle/>
+                    <a:p>
+                      <a:pPr algn="ctr">
+                        <a:defRPr sz="900" b="0">
+                          <a:solidFill>
+                            <a:srgbClr val="D34347"/>
+                          </a:solidFill>
+                          <a:latin typeface="Microsoft YaHei"/>
+                        </a:defRPr>
+                      </a:pPr>
+                      <a:r>
+                        <a:t>7.3</a:t>
+                      </a:r>
+                    </a:p>
+                  </a:txBody>
+                  <a:tcPr marL="54864" marR="54864">
+                    <a:solidFill>
+                      <a:srgbClr val="FFFFFF"/>
+                    </a:solidFill>
+                  </a:tcPr>
+                </a:tc>
+                <a:tc>
+                  <a:txBody>
+                    <a:bodyPr/>
+                    <a:lstStyle/>
+                    <a:p>
+                      <a:pPr algn="ctr">
+                        <a:defRPr sz="900" b="0">
+                          <a:solidFill>
+                            <a:srgbClr val="233242"/>
+                          </a:solidFill>
+                          <a:latin typeface="Microsoft YaHei"/>
+                        </a:defRPr>
+                      </a:pPr>
+                      <a:r>
+                        <a:t>1只</a:t>
+                      </a:r>
+                    </a:p>
+                  </a:txBody>
+                  <a:tcPr marL="54864" marR="54864">
+                    <a:solidFill>
+                      <a:srgbClr val="FFFFFF"/>
+                    </a:solidFill>
+                  </a:tcPr>
+                </a:tc>
+              </a:tr>
+              <a:tr h="429768">
+                <a:tc>
+                  <a:txBody>
+                    <a:bodyPr/>
+                    <a:lstStyle/>
+                    <a:p>
+                      <a:pPr algn="ctr">
+                        <a:defRPr sz="900" b="0">
+                          <a:solidFill>
+                            <a:srgbClr val="233242"/>
+                          </a:solidFill>
+                          <a:latin typeface="Microsoft YaHei"/>
+                        </a:defRPr>
+                      </a:pPr>
+                      <a:r>
+                        <a:t>6</a:t>
+                      </a:r>
+                    </a:p>
+                  </a:txBody>
+                  <a:tcPr marL="54864" marR="54864">
+                    <a:solidFill>
+                      <a:srgbClr val="F7F9FC"/>
+                    </a:solidFill>
+                  </a:tcPr>
+                </a:tc>
+                <a:tc>
+                  <a:txBody>
+                    <a:bodyPr/>
+                    <a:lstStyle/>
+                    <a:p>
+                      <a:pPr algn="l">
+                        <a:defRPr sz="900" b="1">
+                          <a:solidFill>
+                            <a:srgbClr val="233242"/>
+                          </a:solidFill>
+                          <a:latin typeface="Microsoft YaHei"/>
+                        </a:defRPr>
+                      </a:pPr>
+                      <a:r>
+                        <a:t>电力</a:t>
+                      </a:r>
+                    </a:p>
+                  </a:txBody>
+                  <a:tcPr marL="54864" marR="54864">
+                    <a:solidFill>
+                      <a:srgbClr val="F7F9FC"/>
+                    </a:solidFill>
+                  </a:tcPr>
+                </a:tc>
+                <a:tc>
+                  <a:txBody>
+                    <a:bodyPr/>
+                    <a:lstStyle/>
+                    <a:p>
+                      <a:pPr algn="ctr">
+                        <a:defRPr sz="900" b="0">
+                          <a:solidFill>
+                            <a:srgbClr val="D34347"/>
+                          </a:solidFill>
+                          <a:latin typeface="Microsoft YaHei"/>
+                        </a:defRPr>
+                      </a:pPr>
+                      <a:r>
+                        <a:t>6.2</a:t>
+                      </a:r>
+                    </a:p>
+                  </a:txBody>
+                  <a:tcPr marL="54864" marR="54864">
+                    <a:solidFill>
+                      <a:srgbClr val="F7F9FC"/>
+                    </a:solidFill>
+                  </a:tcPr>
+                </a:tc>
+                <a:tc>
+                  <a:txBody>
+                    <a:bodyPr/>
+                    <a:lstStyle/>
+                    <a:p>
+                      <a:pPr algn="ctr">
+                        <a:defRPr sz="900" b="0">
+                          <a:solidFill>
+                            <a:srgbClr val="233242"/>
+                          </a:solidFill>
+                          <a:latin typeface="Microsoft YaHei"/>
+                        </a:defRPr>
+                      </a:pPr>
+                      <a:r>
+                        <a:t>1只</a:t>
+                      </a:r>
+                    </a:p>
+                  </a:txBody>
+                  <a:tcPr marL="54864" marR="54864">
+                    <a:solidFill>
+                      <a:srgbClr val="F7F9FC"/>
+                    </a:solidFill>
+                  </a:tcPr>
+                </a:tc>
+              </a:tr>
             </a:tbl>
           </a:graphicData>
         </a:graphic>
@@ -8630,7 +8630,7 @@
                 </a:solidFill>
                 <a:latin typeface="Microsoft YaHei"/>
               </a:rPr>
-              <a:t>67.7 分</a:t>
+              <a:t>64.5 分</a:t>
             </a:r>
           </a:p>
         </p:txBody>
@@ -8714,7 +8714,7 @@
                 </a:solidFill>
                 <a:latin typeface="Microsoft YaHei"/>
               </a:rPr>
-              <a:t>空转多→多 2 只｜空→空转多 23 只｜多占比 30.6%</a:t>
+              <a:t>空转多→多 2 只｜空→空转多 21 只｜多占比 29.0%</a:t>
             </a:r>
           </a:p>
         </p:txBody>
@@ -8846,7 +8846,7 @@
                 </a:solidFill>
                 <a:latin typeface="Microsoft YaHei"/>
               </a:rPr>
-              <a:t>AI应用</a:t>
+              <a:t>药</a:t>
             </a:r>
           </a:p>
         </p:txBody>
@@ -8888,7 +8888,7 @@
                 </a:solidFill>
                 <a:latin typeface="Microsoft YaHei"/>
               </a:rPr>
-              <a:t>31.7 分</a:t>
+              <a:t>16.3 分</a:t>
             </a:r>
           </a:p>
         </p:txBody>
@@ -8930,7 +8930,7 @@
                 </a:solidFill>
                 <a:latin typeface="Microsoft YaHei"/>
               </a:rPr>
-              <a:t>空转多→多 0→5；反向转空 1 只</a:t>
+              <a:t>空转多→多 2→4；反向转空 3 只</a:t>
             </a:r>
           </a:p>
         </p:txBody>
@@ -8972,7 +8972,7 @@
                 </a:solidFill>
                 <a:latin typeface="Microsoft YaHei"/>
               </a:rPr>
-              <a:t>空转多→多 5 只｜空→空转多 14 只｜多占比 23.9%</a:t>
+              <a:t>空转多→多 4 只｜空→空转多 18 只｜多占比 13.0%</a:t>
             </a:r>
           </a:p>
         </p:txBody>
@@ -9039,7 +9039,7 @@
             <a:avLst/>
           </a:prstGeom>
           <a:solidFill>
-            <a:srgbClr val="D34347"/>
+            <a:srgbClr val="E88B36"/>
           </a:solidFill>
           <a:ln>
             <a:noFill/>
@@ -9104,7 +9104,7 @@
                 </a:solidFill>
                 <a:latin typeface="Microsoft YaHei"/>
               </a:rPr>
-              <a:t>MLCC</a:t>
+              <a:t>AI应用</a:t>
             </a:r>
           </a:p>
         </p:txBody>
@@ -9142,11 +9142,11 @@
             <a:r>
               <a:rPr sz="950" b="1" i="0">
                 <a:solidFill>
-                  <a:srgbClr val="D34347"/>
+                  <a:srgbClr val="E88B36"/>
                 </a:solidFill>
                 <a:latin typeface="Microsoft YaHei"/>
               </a:rPr>
-              <a:t>31.2 分</a:t>
+              <a:t>14.8 分</a:t>
             </a:r>
           </a:p>
         </p:txBody>
@@ -9188,7 +9188,7 @@
                 </a:solidFill>
                 <a:latin typeface="Microsoft YaHei"/>
               </a:rPr>
-              <a:t>空→多跳级 1 只；空转多→多 0→1</a:t>
+              <a:t>空转多→多 0→2；反向转空 2 只</a:t>
             </a:r>
           </a:p>
         </p:txBody>
@@ -9230,7 +9230,7 @@
                 </a:solidFill>
                 <a:latin typeface="Microsoft YaHei"/>
               </a:rPr>
-              <a:t>空转多→多 1 只｜空→空转多 0 只｜多占比 18.8%</a:t>
+              <a:t>空转多→多 2 只｜空→空转多 9 只｜多占比 19.7%</a:t>
             </a:r>
           </a:p>
         </p:txBody>
@@ -9297,7 +9297,7 @@
             <a:avLst/>
           </a:prstGeom>
           <a:solidFill>
-            <a:srgbClr val="E88B36"/>
+            <a:srgbClr val="F0B744"/>
           </a:solidFill>
           <a:ln>
             <a:noFill/>
@@ -9362,7 +9362,7 @@
                 </a:solidFill>
                 <a:latin typeface="Microsoft YaHei"/>
               </a:rPr>
-              <a:t>药</a:t>
+              <a:t>黄金白银</a:t>
             </a:r>
           </a:p>
         </p:txBody>
@@ -9400,11 +9400,11 @@
             <a:r>
               <a:rPr sz="950" b="1" i="0">
                 <a:solidFill>
-                  <a:srgbClr val="E88B36"/>
+                  <a:srgbClr val="F0B744"/>
                 </a:solidFill>
                 <a:latin typeface="Microsoft YaHei"/>
               </a:rPr>
-              <a:t>16.9 分</a:t>
+              <a:t>9.1 分</a:t>
             </a:r>
           </a:p>
         </p:txBody>
@@ -9446,7 +9446,7 @@
                 </a:solidFill>
                 <a:latin typeface="Microsoft YaHei"/>
               </a:rPr>
-              <a:t>空转多→多 2→3；反向转空 2 只</a:t>
+              <a:t>空→空转多蓄势 2 只</a:t>
             </a:r>
           </a:p>
         </p:txBody>
@@ -9488,7 +9488,7 @@
                 </a:solidFill>
                 <a:latin typeface="Microsoft YaHei"/>
               </a:rPr>
-              <a:t>空转多→多 3 只｜空→空转多 19 只｜多占比 13.2%</a:t>
+              <a:t>空转多→多 0 只｜空→空转多 2 只｜多占比 0.0%</a:t>
             </a:r>
           </a:p>
         </p:txBody>
@@ -9555,7 +9555,7 @@
             <a:avLst/>
           </a:prstGeom>
           <a:solidFill>
-            <a:srgbClr val="D34347"/>
+            <a:srgbClr val="E88B36"/>
           </a:solidFill>
           <a:ln>
             <a:noFill/>
@@ -9658,11 +9658,11 @@
             <a:r>
               <a:rPr sz="950" b="1" i="0">
                 <a:solidFill>
-                  <a:srgbClr val="D34347"/>
+                  <a:srgbClr val="E88B36"/>
                 </a:solidFill>
                 <a:latin typeface="Microsoft YaHei"/>
               </a:rPr>
-              <a:t>14.6 分</a:t>
+              <a:t>7.3 分</a:t>
             </a:r>
           </a:p>
         </p:txBody>
@@ -9704,7 +9704,7 @@
                 </a:solidFill>
                 <a:latin typeface="Microsoft YaHei"/>
               </a:rPr>
-              <a:t>空→多跳级 1 只；空转多→多 0→1</a:t>
+              <a:t>空转多→多 0→1</a:t>
             </a:r>
           </a:p>
         </p:txBody>
@@ -9746,7 +9746,7 @@
                 </a:solidFill>
                 <a:latin typeface="Microsoft YaHei"/>
               </a:rPr>
-              <a:t>空转多→多 1 只｜空→空转多 1 只｜多占比 4.9%</a:t>
+              <a:t>空转多→多 1 只｜空→空转多 1 只｜多占比 2.4%</a:t>
             </a:r>
           </a:p>
         </p:txBody>
@@ -9813,7 +9813,7 @@
             <a:avLst/>
           </a:prstGeom>
           <a:solidFill>
-            <a:srgbClr val="F0B744"/>
+            <a:srgbClr val="E88B36"/>
           </a:solidFill>
           <a:ln>
             <a:noFill/>
@@ -9878,7 +9878,7 @@
                 </a:solidFill>
                 <a:latin typeface="Microsoft YaHei"/>
               </a:rPr>
-              <a:t>黄金白银</a:t>
+              <a:t>电力</a:t>
             </a:r>
           </a:p>
         </p:txBody>
@@ -9916,11 +9916,11 @@
             <a:r>
               <a:rPr sz="950" b="1" i="0">
                 <a:solidFill>
-                  <a:srgbClr val="F0B744"/>
+                  <a:srgbClr val="E88B36"/>
                 </a:solidFill>
                 <a:latin typeface="Microsoft YaHei"/>
               </a:rPr>
-              <a:t>9.1 分</a:t>
+              <a:t>6.2 分</a:t>
             </a:r>
           </a:p>
         </p:txBody>
@@ -9962,7 +9962,7 @@
                 </a:solidFill>
                 <a:latin typeface="Microsoft YaHei"/>
               </a:rPr>
-              <a:t>空→空转多蓄势 2 只</a:t>
+              <a:t>空转多→多 1→1；反向转空 1 只</a:t>
             </a:r>
           </a:p>
         </p:txBody>
@@ -10004,7 +10004,7 @@
                 </a:solidFill>
                 <a:latin typeface="Microsoft YaHei"/>
               </a:rPr>
-              <a:t>空转多→多 0 只｜空→空转多 2 只｜多占比 0.0%</a:t>
+              <a:t>空转多→多 1 只｜空→空转多 1 只｜多占比 9.4%</a:t>
             </a:r>
           </a:p>
         </p:txBody>
@@ -10133,7 +10133,7 @@
                 </a:solidFill>
                 <a:latin typeface="Microsoft YaHei"/>
               </a:rPr>
-              <a:t>算力 转空 9 只｜电网设备 转空 8 只｜半导体芯片 转空 5 只｜存储 转空 3 只</a:t>
+              <a:t>算力 转空 10 只｜电网设备 转空 9 只｜半导体芯片 转空 6 只｜存储 转空 4 只</a:t>
             </a:r>
           </a:p>
         </p:txBody>

</xml_diff>